<commit_message>
feat: complete VeriVoice Live architecture, tests, and documentation
</commit_message>
<xml_diff>
--- a/docs/submission/VeriVoice_UNESCO_Pitch_Presentation_2026.pptx
+++ b/docs/submission/VeriVoice_UNESCO_Pitch_Presentation_2026.pptx
@@ -3380,15 +3380,15 @@
               </a:defRPr>
             </a:pPr>
             <a:r>
-              <a:t>• Hamza Imran (Team Leader, Chief Architect &amp; Full-Stack AI Engineer · Pakistan)</a:t>
+              <a:t>• Hamza Imran (Team Leader, Chief Systems Architect &amp; Full-Stack AI Engineer · Pakistan · hamza135252@gmail.com)</a:t>
             </a:r>
             <a:br/>
             <a:r>
-              <a:t>• Carla Yuliana Martinez Quiroz (AI Systems &amp; Media Production · Mexico)  |  Maryam Amjad (Frontend &amp; UX Engineer · Pakistan)</a:t>
+              <a:t>• Carla Yuliana Martinez Quiroz (AI Systems Documentation &amp; Media Production · Mexico)  |  Maryam Amjad (Frontend Developer · Pakistan)</a:t>
             </a:r>
             <a:br/>
             <a:r>
-              <a:t>• Ilham Kurnia Gustavakuan (Education Specialist · Indonesia)  |  Muhamad Rafi (Technical Architect)  |  Andini B. Soleman (Civic Lead)</a:t>
+              <a:t>• Ilham Kurnia Gustavakuan (Education Specialist · Indonesia)  |  Muhamad Rafi (Team Accountant)  |  Andini B. Soleman (Team Accountant)</a:t>
             </a:r>
           </a:p>
         </p:txBody>
@@ -4731,7 +4731,7 @@
               </a:defRPr>
             </a:pPr>
             <a:r>
-              <a:t>End-to-End Verification Pipeline: Bounded AI &amp; 0% Hallucination</a:t>
+              <a:t>End-to-End Verification Pipeline: Bounded AI &amp; Citation Integrity</a:t>
             </a:r>
           </a:p>
         </p:txBody>
@@ -4963,7 +4963,7 @@
               </a:defRPr>
             </a:pPr>
             <a:r>
-              <a:t>2. 12 Domains</a:t>
+              <a:t>2. 15 Domains</a:t>
             </a:r>
           </a:p>
           <a:p>
@@ -4975,7 +4975,7 @@
               </a:defRPr>
             </a:pPr>
             <a:r>
-              <a:t>Health, Climate, AI Disinfo, Disaster, Space, Science</a:t>
+              <a:t>Health, Climate, AI Disinfo, Disaster, Space, Science, etc.</a:t>
             </a:r>
           </a:p>
         </p:txBody>
@@ -5830,7 +5830,7 @@
             <a:br/>
             <a:br/>
             <a:r>
-              <a:t>Empowers rural mothers, students, and elders to verify rumors directly in family WhatsApp and community Discord channels in under 1.8 seconds.</a:t>
+              <a:t>Empowers rural mothers, students, and elders to verify rumors directly in community Discord channels and mobile web in under 1.8 seconds.</a:t>
             </a:r>
           </a:p>
         </p:txBody>
@@ -6151,7 +6151,7 @@
             <a:br/>
             <a:br/>
             <a:r>
-              <a:t>Physical placards provide instant QR-code 'Quick Start Kits' connecting directly to WhatsApp—zero app downloads needed.</a:t>
+              <a:t>Physical placards provide instant QR-code 'Quick Start Kits' connecting directly to Web and messaging—zero app downloads needed.</a:t>
             </a:r>
           </a:p>
         </p:txBody>
@@ -6364,7 +6364,7 @@
               </a:defRPr>
             </a:pPr>
             <a:r>
-              <a:t>Routine queries (80-90%) run on Groq LPU inference, costing &lt; $0.0012 per query.</a:t>
+              <a:t>Routine queries run on Groq LPU inference, costing &lt; $0.0012 per query.</a:t>
             </a:r>
             <a:br/>
             <a:br/>
@@ -6545,7 +6545,7 @@
               </a:defRPr>
             </a:pPr>
             <a:r>
-              <a:t>Empirical Feasibility: 21 Test Suites, 170 Tests &amp; Sub-1.8s Latency</a:t>
+              <a:t>Empirical Feasibility: 22 Test Suites, 180 Tests &amp; Sub-1.8s Latency</a:t>
             </a:r>
           </a:p>
         </p:txBody>
@@ -6685,11 +6685,11 @@
               </a:defRPr>
             </a:pPr>
             <a:r>
-              <a:t>• 21 Test Suites / 170 Automated Tests Passing (100% Green)</a:t>
+              <a:t>• 22 Test Suites / 180 Automated Tests Passing (100% Green)</a:t>
             </a:r>
             <a:br/>
             <a:r>
-              <a:t>• Specialized tests in tests/unescoAuthority.test.js &amp; tests/security.test.js</a:t>
+              <a:t>• Specialized tests in tests/unescoAuthority.test.js &amp; tests/chaosResilience.test.js</a:t>
             </a:r>
             <a:br/>
             <a:r>
@@ -6921,7 +6921,7 @@
               </a:defRPr>
             </a:pPr>
             <a:r>
-              <a:t>• Production Frontend (Vercel): frontend-nu-six-72.vercel.app</a:t>
+              <a:t>• Production Frontend (Vercel): verivoice-ten.vercel.app</a:t>
             </a:r>
             <a:br/>
             <a:r>

</xml_diff>